<commit_message>
Add a Watch this first icebreaker slide to intern onboarding training.
Co-authored-by: Cursor <cursoragent@cursor.com>
</commit_message>
<xml_diff>
--- a/docs/intern-guide/assets/sitguru-internship-onboarding-inprocessing-spring-2027.pptx
+++ b/docs/intern-guide/assets/sitguru-internship-onboarding-inprocessing-spring-2027.pptx
@@ -6,6 +6,7 @@
   </p:sldMasterIdLst>
   <p:sldIdLst>
     <p:sldId id="256" r:id="rId7"/>
+    <p:sldId id="280" r:id="rId31"/>
     <p:sldId id="257" r:id="rId8"/>
     <p:sldId id="258" r:id="rId9"/>
     <p:sldId id="259" r:id="rId10"/>
@@ -4351,7 +4352,7 @@
                 </a:solidFill>
                 <a:latin typeface="Calibri"/>
               </a:rPr>
-              <a:t>10</a:t>
+              <a:t>11</a:t>
             </a:r>
           </a:p>
         </p:txBody>
@@ -5595,7 +5596,7 @@
                 </a:solidFill>
                 <a:latin typeface="Calibri"/>
               </a:rPr>
-              <a:t>11</a:t>
+              <a:t>12</a:t>
             </a:r>
           </a:p>
         </p:txBody>
@@ -5986,7 +5987,7 @@
                 </a:solidFill>
                 <a:latin typeface="Calibri"/>
               </a:rPr>
-              <a:t>12</a:t>
+              <a:t>13</a:t>
             </a:r>
           </a:p>
         </p:txBody>
@@ -7472,7 +7473,7 @@
                 </a:solidFill>
                 <a:latin typeface="Calibri"/>
               </a:rPr>
-              <a:t>13</a:t>
+              <a:t>14</a:t>
             </a:r>
           </a:p>
         </p:txBody>
@@ -8541,7 +8542,7 @@
                 </a:solidFill>
                 <a:latin typeface="Calibri"/>
               </a:rPr>
-              <a:t>14</a:t>
+              <a:t>15</a:t>
             </a:r>
           </a:p>
         </p:txBody>
@@ -10595,7 +10596,7 @@
                 </a:solidFill>
                 <a:latin typeface="Calibri"/>
               </a:rPr>
-              <a:t>15</a:t>
+              <a:t>16</a:t>
             </a:r>
           </a:p>
         </p:txBody>
@@ -11904,7 +11905,7 @@
                 </a:solidFill>
                 <a:latin typeface="Calibri"/>
               </a:rPr>
-              <a:t>16</a:t>
+              <a:t>17</a:t>
             </a:r>
           </a:p>
         </p:txBody>
@@ -12973,7 +12974,7 @@
                 </a:solidFill>
                 <a:latin typeface="Calibri"/>
               </a:rPr>
-              <a:t>17</a:t>
+              <a:t>18</a:t>
             </a:r>
           </a:p>
         </p:txBody>
@@ -13849,7 +13850,7 @@
                 </a:solidFill>
                 <a:latin typeface="Calibri"/>
               </a:rPr>
-              <a:t>18</a:t>
+              <a:t>19</a:t>
             </a:r>
           </a:p>
         </p:txBody>
@@ -14161,7 +14162,7 @@
                 </a:solidFill>
                 <a:latin typeface="Calibri"/>
               </a:rPr>
-              <a:t>2</a:t>
+              <a:t>3</a:t>
             </a:r>
           </a:p>
         </p:txBody>
@@ -14350,7 +14351,7 @@
                 </a:solidFill>
                 <a:latin typeface="Calibri"/>
               </a:rPr>
-              <a:t>3</a:t>
+              <a:t>4</a:t>
             </a:r>
           </a:p>
         </p:txBody>
@@ -14539,7 +14540,7 @@
                 </a:solidFill>
                 <a:latin typeface="Calibri"/>
               </a:rPr>
-              <a:t>4</a:t>
+              <a:t>5</a:t>
             </a:r>
           </a:p>
         </p:txBody>
@@ -14728,7 +14729,7 @@
                 </a:solidFill>
                 <a:latin typeface="Calibri"/>
               </a:rPr>
-              <a:t>5</a:t>
+              <a:t>6</a:t>
             </a:r>
           </a:p>
         </p:txBody>
@@ -14917,7 +14918,7 @@
                 </a:solidFill>
                 <a:latin typeface="Calibri"/>
               </a:rPr>
-              <a:t>6</a:t>
+              <a:t>7</a:t>
             </a:r>
           </a:p>
         </p:txBody>
@@ -15407,7 +15408,7 @@
                 </a:solidFill>
                 <a:latin typeface="Calibri"/>
               </a:rPr>
-              <a:t>19</a:t>
+              <a:t>20</a:t>
             </a:r>
           </a:p>
         </p:txBody>
@@ -15752,7 +15753,7 @@
                 </a:solidFill>
                 <a:latin typeface="Calibri"/>
               </a:rPr>
-              <a:t>2</a:t>
+              <a:t>3</a:t>
             </a:r>
           </a:p>
         </p:txBody>
@@ -15974,7 +15975,7 @@
                 </a:solidFill>
                 <a:latin typeface="Calibri"/>
               </a:rPr>
-              <a:t>3</a:t>
+              <a:t>4</a:t>
             </a:r>
           </a:p>
         </p:txBody>
@@ -16577,7 +16578,7 @@
                 </a:solidFill>
                 <a:latin typeface="Calibri"/>
               </a:rPr>
-              <a:t>2</a:t>
+              <a:t>3</a:t>
             </a:r>
           </a:p>
         </p:txBody>
@@ -17000,7 +17001,7 @@
                 </a:solidFill>
                 <a:latin typeface="Calibri"/>
               </a:rPr>
-              <a:t>2</a:t>
+              <a:t>3</a:t>
             </a:r>
           </a:p>
         </p:txBody>
@@ -17189,7 +17190,7 @@
                 </a:solidFill>
                 <a:latin typeface="Calibri"/>
               </a:rPr>
-              <a:t>3</a:t>
+              <a:t>4</a:t>
             </a:r>
           </a:p>
         </p:txBody>
@@ -17679,7 +17680,7 @@
                 </a:solidFill>
                 <a:latin typeface="Calibri"/>
               </a:rPr>
-              <a:t>20</a:t>
+              <a:t>21</a:t>
             </a:r>
           </a:p>
         </p:txBody>
@@ -18979,7 +18980,7 @@
                 </a:solidFill>
                 <a:latin typeface="Calibri"/>
               </a:rPr>
-              <a:t>21</a:t>
+              <a:t>22</a:t>
             </a:r>
           </a:p>
         </p:txBody>
@@ -20048,7 +20049,7 @@
                 </a:solidFill>
                 <a:latin typeface="Calibri"/>
               </a:rPr>
-              <a:t>22</a:t>
+              <a:t>23</a:t>
             </a:r>
           </a:p>
         </p:txBody>
@@ -21183,7 +21184,7 @@
                 </a:solidFill>
                 <a:latin typeface="Calibri"/>
               </a:rPr>
-              <a:t>23</a:t>
+              <a:t>24</a:t>
             </a:r>
           </a:p>
         </p:txBody>
@@ -21462,7 +21463,7 @@
                 </a:solidFill>
                 <a:latin typeface="Calibri"/>
               </a:rPr>
-              <a:t>2</a:t>
+              <a:t>3</a:t>
             </a:r>
           </a:p>
         </p:txBody>
@@ -21618,7 +21619,7 @@
                 </a:solidFill>
                 <a:latin typeface="Calibri"/>
               </a:rPr>
-              <a:t>3</a:t>
+              <a:t>4</a:t>
             </a:r>
           </a:p>
         </p:txBody>
@@ -21774,7 +21775,7 @@
                 </a:solidFill>
                 <a:latin typeface="Calibri"/>
               </a:rPr>
-              <a:t>4</a:t>
+              <a:t>5</a:t>
             </a:r>
           </a:p>
         </p:txBody>
@@ -21930,7 +21931,7 @@
                 </a:solidFill>
                 <a:latin typeface="Calibri"/>
               </a:rPr>
-              <a:t>5</a:t>
+              <a:t>6</a:t>
             </a:r>
           </a:p>
         </p:txBody>
@@ -22086,7 +22087,7 @@
                 </a:solidFill>
                 <a:latin typeface="Calibri"/>
               </a:rPr>
-              <a:t>6</a:t>
+              <a:t>7</a:t>
             </a:r>
           </a:p>
         </p:txBody>
@@ -22242,7 +22243,7 @@
                 </a:solidFill>
                 <a:latin typeface="Calibri"/>
               </a:rPr>
-              <a:t>7</a:t>
+              <a:t>8</a:t>
             </a:r>
           </a:p>
         </p:txBody>
@@ -22398,7 +22399,7 @@
                 </a:solidFill>
                 <a:latin typeface="Calibri"/>
               </a:rPr>
-              <a:t>8</a:t>
+              <a:t>9</a:t>
             </a:r>
           </a:p>
         </p:txBody>
@@ -22872,7 +22873,717 @@
                 </a:solidFill>
                 <a:latin typeface="Calibri"/>
               </a:rPr>
-              <a:t>24</a:t>
+              <a:t>25</a:t>
+            </a:r>
+          </a:p>
+        </p:txBody>
+      </p:sp>
+    </p:spTree>
+  </p:cSld>
+  <p:clrMapOvr>
+    <a:masterClrMapping/>
+  </p:clrMapOvr>
+</p:sld>
+</file>
+
+<file path=ppt/slides/slide25.xml><?xml version="1.0" encoding="utf-8"?>
+<p:sld xmlns:a="http://schemas.openxmlformats.org/drawingml/2006/main" xmlns:p="http://schemas.openxmlformats.org/presentationml/2006/main" xmlns:r="http://schemas.openxmlformats.org/officeDocument/2006/relationships">
+  <p:cSld>
+    <p:spTree>
+      <p:nvGrpSpPr>
+        <p:cNvPr id="1" name=""/>
+        <p:cNvGrpSpPr/>
+        <p:nvPr/>
+      </p:nvGrpSpPr>
+      <p:grpSpPr/>
+      <p:sp>
+        <p:nvSpPr>
+          <p:cNvPr id="2" name="Rectangle 1"/>
+          <p:cNvSpPr/>
+          <p:nvPr/>
+        </p:nvSpPr>
+        <p:spPr>
+          <a:xfrm>
+            <a:off x="0" y="0"/>
+            <a:ext cx="12191695" cy="6858000"/>
+          </a:xfrm>
+          <a:prstGeom prst="rect">
+            <a:avLst/>
+          </a:prstGeom>
+          <a:solidFill>
+            <a:srgbClr val="F3F8F4"/>
+          </a:solidFill>
+          <a:ln>
+            <a:noFill/>
+          </a:ln>
+        </p:spPr>
+        <p:style>
+          <a:lnRef idx="1">
+            <a:schemeClr val="accent1"/>
+          </a:lnRef>
+          <a:fillRef idx="3">
+            <a:schemeClr val="accent1"/>
+          </a:fillRef>
+          <a:effectRef idx="2">
+            <a:schemeClr val="accent1"/>
+          </a:effectRef>
+          <a:fontRef idx="minor">
+            <a:schemeClr val="lt1"/>
+          </a:fontRef>
+        </p:style>
+        <p:txBody>
+          <a:bodyPr rtlCol="0" anchor="ctr"/>
+          <a:lstStyle/>
+          <a:p>
+            <a:pPr algn="ctr"/>
+          </a:p>
+        </p:txBody>
+      </p:sp>
+      <p:sp>
+        <p:nvSpPr>
+          <p:cNvPr id="3" name="Rectangle 2"/>
+          <p:cNvSpPr/>
+          <p:nvPr/>
+        </p:nvSpPr>
+        <p:spPr>
+          <a:xfrm>
+            <a:off x="0" y="0"/>
+            <a:ext cx="12191695" cy="1078992"/>
+          </a:xfrm>
+          <a:prstGeom prst="rect">
+            <a:avLst/>
+          </a:prstGeom>
+          <a:solidFill>
+            <a:srgbClr val="166534"/>
+          </a:solidFill>
+          <a:ln>
+            <a:noFill/>
+          </a:ln>
+        </p:spPr>
+        <p:style>
+          <a:lnRef idx="1">
+            <a:schemeClr val="accent1"/>
+          </a:lnRef>
+          <a:fillRef idx="3">
+            <a:schemeClr val="accent1"/>
+          </a:fillRef>
+          <a:effectRef idx="2">
+            <a:schemeClr val="accent1"/>
+          </a:effectRef>
+          <a:fontRef idx="minor">
+            <a:schemeClr val="lt1"/>
+          </a:fontRef>
+        </p:style>
+        <p:txBody>
+          <a:bodyPr rtlCol="0" anchor="ctr"/>
+          <a:lstStyle/>
+          <a:p>
+            <a:pPr algn="ctr"/>
+          </a:p>
+        </p:txBody>
+      </p:sp>
+      <p:sp>
+        <p:nvSpPr>
+          <p:cNvPr id="4" name="Rectangle 3"/>
+          <p:cNvSpPr/>
+          <p:nvPr/>
+        </p:nvSpPr>
+        <p:spPr>
+          <a:xfrm>
+            <a:off x="0" y="1078992"/>
+            <a:ext cx="12191695" cy="54864"/>
+          </a:xfrm>
+          <a:prstGeom prst="rect">
+            <a:avLst/>
+          </a:prstGeom>
+          <a:solidFill>
+            <a:srgbClr val="102417"/>
+          </a:solidFill>
+          <a:ln>
+            <a:noFill/>
+          </a:ln>
+        </p:spPr>
+        <p:style>
+          <a:lnRef idx="1">
+            <a:schemeClr val="accent1"/>
+          </a:lnRef>
+          <a:fillRef idx="3">
+            <a:schemeClr val="accent1"/>
+          </a:fillRef>
+          <a:effectRef idx="2">
+            <a:schemeClr val="accent1"/>
+          </a:effectRef>
+          <a:fontRef idx="minor">
+            <a:schemeClr val="lt1"/>
+          </a:fontRef>
+        </p:style>
+        <p:txBody>
+          <a:bodyPr rtlCol="0" anchor="ctr"/>
+          <a:lstStyle/>
+          <a:p>
+            <a:pPr algn="ctr"/>
+          </a:p>
+        </p:txBody>
+      </p:sp>
+      <p:sp>
+        <p:nvSpPr>
+          <p:cNvPr id="5" name="TextBox 4"/>
+          <p:cNvSpPr txBox="1"/>
+          <p:nvPr/>
+        </p:nvSpPr>
+        <p:spPr>
+          <a:xfrm>
+            <a:off x="384048" y="164592"/>
+            <a:ext cx="9692640" cy="475488"/>
+          </a:xfrm>
+          <a:prstGeom prst="rect">
+            <a:avLst/>
+          </a:prstGeom>
+          <a:noFill/>
+        </p:spPr>
+        <p:txBody>
+          <a:bodyPr wrap="square" anchor="ctr"/>
+          <a:lstStyle/>
+          <a:p>
+            <a:pPr algn="l"/>
+            <a:r>
+              <a:rPr sz="2600" b="1">
+                <a:solidFill>
+                  <a:srgbClr val="FFFFFF"/>
+                </a:solidFill>
+                <a:latin typeface="Calibri"/>
+              </a:rPr>
+              <a:t>Watch this first</a:t>
+            </a:r>
+          </a:p>
+        </p:txBody>
+      </p:sp>
+      <p:sp>
+        <p:nvSpPr>
+          <p:cNvPr id="6" name="TextBox 5"/>
+          <p:cNvSpPr txBox="1"/>
+          <p:nvPr/>
+        </p:nvSpPr>
+        <p:spPr>
+          <a:xfrm>
+            <a:off x="384048" y="621792"/>
+            <a:ext cx="9692640" cy="347472"/>
+          </a:xfrm>
+          <a:prstGeom prst="rect">
+            <a:avLst/>
+          </a:prstGeom>
+          <a:noFill/>
+        </p:spPr>
+        <p:txBody>
+          <a:bodyPr wrap="square" anchor="t"/>
+          <a:lstStyle/>
+          <a:p>
+            <a:pPr algn="l"/>
+            <a:r>
+              <a:rPr sz="1300" b="0">
+                <a:solidFill>
+                  <a:srgbClr val="CFE6D5"/>
+                </a:solidFill>
+                <a:latin typeface="Calibri"/>
+              </a:rPr>
+              <a:t>Set the tone. Break the ice. Then we onboard.</a:t>
+            </a:r>
+          </a:p>
+        </p:txBody>
+      </p:sp>
+      <p:sp>
+        <p:nvSpPr>
+          <p:cNvPr id="7" name="Rounded Rectangle 6"/>
+          <p:cNvSpPr/>
+          <p:nvPr/>
+        </p:nvSpPr>
+        <p:spPr>
+          <a:xfrm>
+            <a:off x="10561320" y="201168"/>
+            <a:ext cx="1261872" cy="676656"/>
+          </a:xfrm>
+          <a:prstGeom prst="roundRect">
+            <a:avLst>
+              <a:gd name="adj" fmla="val 18000"/>
+            </a:avLst>
+          </a:prstGeom>
+          <a:solidFill>
+            <a:srgbClr val="FFFFFF"/>
+          </a:solidFill>
+          <a:ln>
+            <a:noFill/>
+          </a:ln>
+        </p:spPr>
+        <p:style>
+          <a:lnRef idx="1">
+            <a:schemeClr val="accent1"/>
+          </a:lnRef>
+          <a:fillRef idx="3">
+            <a:schemeClr val="accent1"/>
+          </a:fillRef>
+          <a:effectRef idx="2">
+            <a:schemeClr val="accent1"/>
+          </a:effectRef>
+          <a:fontRef idx="minor">
+            <a:schemeClr val="lt1"/>
+          </a:fontRef>
+        </p:style>
+        <p:txBody>
+          <a:bodyPr rtlCol="0" anchor="ctr"/>
+          <a:lstStyle/>
+          <a:p>
+            <a:pPr algn="ctr"/>
+          </a:p>
+        </p:txBody>
+      </p:sp>
+      <p:pic>
+        <p:nvPicPr>
+          <p:cNvPr id="8" name="Picture 7" descr="image.jpg"/>
+          <p:cNvPicPr>
+            <a:picLocks noChangeAspect="1"/>
+          </p:cNvPicPr>
+          <p:nvPr/>
+        </p:nvPicPr>
+        <p:blipFill>
+          <a:blip r:embed="rId2"/>
+          <a:stretch>
+            <a:fillRect/>
+          </a:stretch>
+        </p:blipFill>
+        <p:spPr>
+          <a:xfrm>
+            <a:off x="10808208" y="256032"/>
+            <a:ext cx="768096" cy="566928"/>
+          </a:xfrm>
+          <a:prstGeom prst="rect">
+            <a:avLst/>
+          </a:prstGeom>
+        </p:spPr>
+      </p:pic>
+      <p:sp>
+        <p:nvSpPr>
+          <p:cNvPr id="9" name="TextBox 8"/>
+          <p:cNvSpPr txBox="1"/>
+          <p:nvPr/>
+        </p:nvSpPr>
+        <p:spPr>
+          <a:xfrm>
+            <a:off x="384048" y="1335024"/>
+            <a:ext cx="6537960" cy="1051560"/>
+          </a:xfrm>
+          <a:prstGeom prst="rect">
+            <a:avLst/>
+          </a:prstGeom>
+          <a:noFill/>
+        </p:spPr>
+        <p:txBody>
+          <a:bodyPr wrap="square" anchor="t"/>
+          <a:lstStyle/>
+          <a:p>
+            <a:pPr algn="l"/>
+            <a:r>
+              <a:rPr sz="1800" b="1">
+                <a:solidFill>
+                  <a:srgbClr val="0F172A"/>
+                </a:solidFill>
+                <a:latin typeface="Calibri"/>
+              </a:rPr>
+              <a:t>Hit play together — or watch on your own. This is the icebreaker before the agreement, hours, and portal work. Rogue energy: high-energy, loving, then we get to work.</a:t>
+            </a:r>
+          </a:p>
+        </p:txBody>
+      </p:sp>
+      <p:sp>
+        <p:nvSpPr>
+          <p:cNvPr id="10" name="TextBox 9"/>
+          <p:cNvSpPr txBox="1"/>
+          <p:nvPr/>
+        </p:nvSpPr>
+        <p:spPr>
+          <a:xfrm>
+            <a:off x="384048" y="2450592"/>
+            <a:ext cx="6537960" cy="777240"/>
+          </a:xfrm>
+          <a:prstGeom prst="rect">
+            <a:avLst/>
+          </a:prstGeom>
+          <a:noFill/>
+        </p:spPr>
+        <p:txBody>
+          <a:bodyPr wrap="square" anchor="t"/>
+          <a:lstStyle/>
+          <a:p>
+            <a:pPr algn="l"/>
+            <a:r>
+              <a:rPr sz="1500" b="0">
+                <a:solidFill>
+                  <a:srgbClr val="475569"/>
+                </a:solidFill>
+                <a:latin typeface="Calibri"/>
+              </a:rPr>
+              <a:t>Start at 12:29 (t=749s). Official talk title: Why social media deserves a seat in the c-suite.</a:t>
+            </a:r>
+          </a:p>
+        </p:txBody>
+      </p:sp>
+      <p:pic>
+        <p:nvPicPr>
+          <p:cNvPr id="11" name="Picture 10" descr="_yt-Zzv6Opxkt88.jpg">
+            <a:hlinkClick r:id="rId4"/>
+          </p:cNvPr>
+          <p:cNvPicPr>
+            <a:picLocks noChangeAspect="1"/>
+          </p:cNvPicPr>
+          <p:nvPr/>
+        </p:nvPicPr>
+        <p:blipFill>
+          <a:blip r:embed="rId3"/>
+          <a:stretch>
+            <a:fillRect/>
+          </a:stretch>
+        </p:blipFill>
+        <p:spPr>
+          <a:xfrm>
+            <a:off x="7360920" y="1371600"/>
+            <a:ext cx="4434840" cy="2487168"/>
+          </a:xfrm>
+          <a:prstGeom prst="rect">
+            <a:avLst/>
+          </a:prstGeom>
+        </p:spPr>
+      </p:pic>
+      <p:sp>
+        <p:nvSpPr>
+          <p:cNvPr id="12" name="Rounded Rectangle 11">
+            <a:hlinkClick r:id="rId4"/>
+          </p:cNvPr>
+          <p:cNvSpPr/>
+          <p:nvPr/>
+        </p:nvSpPr>
+        <p:spPr>
+          <a:xfrm>
+            <a:off x="9144000" y="2267712"/>
+            <a:ext cx="914400" cy="658368"/>
+          </a:xfrm>
+          <a:prstGeom prst="roundRect">
+            <a:avLst>
+              <a:gd name="adj" fmla="val 25000"/>
+            </a:avLst>
+          </a:prstGeom>
+          <a:solidFill>
+            <a:srgbClr val="166534"/>
+          </a:solidFill>
+          <a:ln>
+            <a:noFill/>
+          </a:ln>
+        </p:spPr>
+        <p:style>
+          <a:lnRef idx="1">
+            <a:schemeClr val="accent1"/>
+          </a:lnRef>
+          <a:fillRef idx="3">
+            <a:schemeClr val="accent1"/>
+          </a:fillRef>
+          <a:effectRef idx="2">
+            <a:schemeClr val="accent1"/>
+          </a:effectRef>
+          <a:fontRef idx="minor">
+            <a:schemeClr val="lt1"/>
+          </a:fontRef>
+        </p:style>
+        <p:txBody>
+          <a:bodyPr rtlCol="0" anchor="ctr"/>
+          <a:lstStyle/>
+          <a:p>
+            <a:pPr algn="ctr"/>
+          </a:p>
+        </p:txBody>
+      </p:sp>
+      <p:sp>
+        <p:nvSpPr>
+          <p:cNvPr id="13" name="TextBox 12"/>
+          <p:cNvSpPr txBox="1"/>
+          <p:nvPr/>
+        </p:nvSpPr>
+        <p:spPr>
+          <a:xfrm>
+            <a:off x="9144000" y="2359152"/>
+            <a:ext cx="914400" cy="475488"/>
+          </a:xfrm>
+          <a:prstGeom prst="rect">
+            <a:avLst/>
+          </a:prstGeom>
+          <a:noFill/>
+        </p:spPr>
+        <p:txBody>
+          <a:bodyPr wrap="square" anchor="ctr"/>
+          <a:lstStyle/>
+          <a:p>
+            <a:pPr algn="ctr"/>
+            <a:r>
+              <a:rPr sz="2200" b="1">
+                <a:solidFill>
+                  <a:srgbClr val="FFFFFF"/>
+                </a:solidFill>
+                <a:latin typeface="Calibri"/>
+              </a:rPr>
+              <a:t>▶</a:t>
+            </a:r>
+          </a:p>
+        </p:txBody>
+      </p:sp>
+      <p:sp>
+        <p:nvSpPr>
+          <p:cNvPr id="14" name="Rounded Rectangle 13">
+            <a:hlinkClick r:id="rId4"/>
+          </p:cNvPr>
+          <p:cNvSpPr/>
+          <p:nvPr/>
+        </p:nvSpPr>
+        <p:spPr>
+          <a:xfrm>
+            <a:off x="384048" y="3383280"/>
+            <a:ext cx="6537960" cy="960120"/>
+          </a:xfrm>
+          <a:prstGeom prst="roundRect">
+            <a:avLst>
+              <a:gd name="adj" fmla="val 12000"/>
+            </a:avLst>
+          </a:prstGeom>
+          <a:solidFill>
+            <a:srgbClr val="166534"/>
+          </a:solidFill>
+          <a:ln>
+            <a:noFill/>
+          </a:ln>
+        </p:spPr>
+        <p:style>
+          <a:lnRef idx="1">
+            <a:schemeClr val="accent1"/>
+          </a:lnRef>
+          <a:fillRef idx="3">
+            <a:schemeClr val="accent1"/>
+          </a:fillRef>
+          <a:effectRef idx="2">
+            <a:schemeClr val="accent1"/>
+          </a:effectRef>
+          <a:fontRef idx="minor">
+            <a:schemeClr val="lt1"/>
+          </a:fontRef>
+        </p:style>
+        <p:txBody>
+          <a:bodyPr rtlCol="0" anchor="ctr"/>
+          <a:lstStyle/>
+          <a:p>
+            <a:pPr algn="ctr"/>
+          </a:p>
+        </p:txBody>
+      </p:sp>
+      <p:sp>
+        <p:nvSpPr>
+          <p:cNvPr id="15" name="TextBox 14"/>
+          <p:cNvSpPr txBox="1"/>
+          <p:nvPr/>
+        </p:nvSpPr>
+        <p:spPr>
+          <a:xfrm>
+            <a:off x="530352" y="3529584"/>
+            <a:ext cx="6263640" cy="658368"/>
+          </a:xfrm>
+          <a:prstGeom prst="rect">
+            <a:avLst/>
+          </a:prstGeom>
+          <a:noFill/>
+        </p:spPr>
+        <p:txBody>
+          <a:bodyPr wrap="square" anchor="ctr"/>
+          <a:lstStyle/>
+          <a:p>
+            <a:pPr algn="ctr"/>
+            <a:r>
+              <a:rPr sz="2200" b="1">
+                <a:solidFill>
+                  <a:srgbClr val="FFFFFF"/>
+                </a:solidFill>
+                <a:latin typeface="Calibri"/>
+              </a:rPr>
+              <a:t>Watch the SitGuru icebreaker  →</a:t>
+            </a:r>
+          </a:p>
+        </p:txBody>
+      </p:sp>
+      <p:sp>
+        <p:nvSpPr>
+          <p:cNvPr id="16" name="TextBox 15"/>
+          <p:cNvSpPr txBox="1"/>
+          <p:nvPr/>
+        </p:nvSpPr>
+        <p:spPr>
+          <a:xfrm>
+            <a:off x="384048" y="4480560"/>
+            <a:ext cx="11430000" cy="384048"/>
+          </a:xfrm>
+          <a:prstGeom prst="rect">
+            <a:avLst/>
+          </a:prstGeom>
+          <a:noFill/>
+        </p:spPr>
+        <p:txBody>
+          <a:bodyPr wrap="square" anchor="t"/>
+          <a:lstStyle/>
+          <a:p>
+            <a:pPr algn="l"/>
+            <a:r>
+              <a:rPr sz="1400" b="1">
+                <a:solidFill>
+                  <a:srgbClr val="166534"/>
+                </a:solidFill>
+                <a:latin typeface="Calibri"/>
+                <a:hlinkClick r:id="rId4"/>
+              </a:rPr>
+              <a:t>https://www.youtube.com/watch?v=Zzv6Opxkt88&amp;t=749s</a:t>
+            </a:r>
+          </a:p>
+        </p:txBody>
+      </p:sp>
+      <p:sp>
+        <p:nvSpPr>
+          <p:cNvPr id="17" name="TextBox 16"/>
+          <p:cNvSpPr txBox="1"/>
+          <p:nvPr/>
+        </p:nvSpPr>
+        <p:spPr>
+          <a:xfrm>
+            <a:off x="384048" y="4919472"/>
+            <a:ext cx="11430000" cy="1371600"/>
+          </a:xfrm>
+          <a:prstGeom prst="rect">
+            <a:avLst/>
+          </a:prstGeom>
+          <a:noFill/>
+        </p:spPr>
+        <p:txBody>
+          <a:bodyPr wrap="square" anchor="t"/>
+          <a:lstStyle/>
+          <a:p>
+            <a:pPr algn="l"/>
+            <a:r>
+              <a:rPr sz="1500" b="0">
+                <a:solidFill>
+                  <a:srgbClr val="475569"/>
+                </a:solidFill>
+                <a:latin typeface="Calibri"/>
+              </a:rPr>
+              <a:t>That exact URL opens at 12:29. No video file lives in this deck — click the link. Then come back for onboarding. Questions: intern@sitguru.com.</a:t>
+            </a:r>
+          </a:p>
+        </p:txBody>
+      </p:sp>
+      <p:sp>
+        <p:nvSpPr>
+          <p:cNvPr id="18" name="Rectangle 17"/>
+          <p:cNvSpPr/>
+          <p:nvPr/>
+        </p:nvSpPr>
+        <p:spPr>
+          <a:xfrm>
+            <a:off x="0" y="6510528"/>
+            <a:ext cx="12191695" cy="347472"/>
+          </a:xfrm>
+          <a:prstGeom prst="rect">
+            <a:avLst/>
+          </a:prstGeom>
+          <a:solidFill>
+            <a:srgbClr val="F3F8F4"/>
+          </a:solidFill>
+          <a:ln>
+            <a:noFill/>
+          </a:ln>
+        </p:spPr>
+        <p:style>
+          <a:lnRef idx="1">
+            <a:schemeClr val="accent1"/>
+          </a:lnRef>
+          <a:fillRef idx="3">
+            <a:schemeClr val="accent1"/>
+          </a:fillRef>
+          <a:effectRef idx="2">
+            <a:schemeClr val="accent1"/>
+          </a:effectRef>
+          <a:fontRef idx="minor">
+            <a:schemeClr val="lt1"/>
+          </a:fontRef>
+        </p:style>
+        <p:txBody>
+          <a:bodyPr rtlCol="0" anchor="ctr"/>
+          <a:lstStyle/>
+          <a:p>
+            <a:pPr algn="ctr"/>
+          </a:p>
+        </p:txBody>
+      </p:sp>
+      <p:sp>
+        <p:nvSpPr>
+          <p:cNvPr id="19" name="TextBox 18"/>
+          <p:cNvSpPr txBox="1"/>
+          <p:nvPr/>
+        </p:nvSpPr>
+        <p:spPr>
+          <a:xfrm>
+            <a:off x="384048" y="6547104"/>
+            <a:ext cx="10515600" cy="274320"/>
+          </a:xfrm>
+          <a:prstGeom prst="rect">
+            <a:avLst/>
+          </a:prstGeom>
+          <a:noFill/>
+        </p:spPr>
+        <p:txBody>
+          <a:bodyPr wrap="square" anchor="ctr"/>
+          <a:lstStyle/>
+          <a:p>
+            <a:pPr algn="l"/>
+            <a:r>
+              <a:rPr sz="800" b="0">
+                <a:solidFill>
+                  <a:srgbClr val="64748B"/>
+                </a:solidFill>
+                <a:latin typeface="Calibri"/>
+              </a:rPr>
+              <a:t>© SitGuru. Proprietary and confidential. This user guide belongs solely to SitGuru and may not be copied, reproduced, distributed, shared, or used in whole or in part without prior written permission from SitGuru.</a:t>
+            </a:r>
+          </a:p>
+        </p:txBody>
+      </p:sp>
+      <p:sp>
+        <p:nvSpPr>
+          <p:cNvPr id="20" name="TextBox 19"/>
+          <p:cNvSpPr txBox="1"/>
+          <p:nvPr/>
+        </p:nvSpPr>
+        <p:spPr>
+          <a:xfrm>
+            <a:off x="10927080" y="6547104"/>
+            <a:ext cx="914400" cy="274320"/>
+          </a:xfrm>
+          <a:prstGeom prst="rect">
+            <a:avLst/>
+          </a:prstGeom>
+          <a:noFill/>
+        </p:spPr>
+        <p:txBody>
+          <a:bodyPr wrap="square" anchor="ctr"/>
+          <a:lstStyle/>
+          <a:p>
+            <a:pPr algn="r"/>
+            <a:r>
+              <a:rPr sz="1000" b="1">
+                <a:solidFill>
+                  <a:srgbClr val="166534"/>
+                </a:solidFill>
+                <a:latin typeface="Calibri"/>
+              </a:rPr>
+              <a:t>2</a:t>
             </a:r>
           </a:p>
         </p:txBody>
@@ -23263,7 +23974,7 @@
                 </a:solidFill>
                 <a:latin typeface="Calibri"/>
               </a:rPr>
-              <a:t>3</a:t>
+              <a:t>4</a:t>
             </a:r>
           </a:p>
         </p:txBody>
@@ -23608,7 +24319,7 @@
                 </a:solidFill>
                 <a:latin typeface="Calibri"/>
               </a:rPr>
-              <a:t>2</a:t>
+              <a:t>3</a:t>
             </a:r>
           </a:p>
         </p:txBody>
@@ -23797,7 +24508,7 @@
                 </a:solidFill>
                 <a:latin typeface="Calibri"/>
               </a:rPr>
-              <a:t>3</a:t>
+              <a:t>4</a:t>
             </a:r>
           </a:p>
         </p:txBody>
@@ -24367,7 +25078,7 @@
                 </a:solidFill>
                 <a:latin typeface="Calibri"/>
               </a:rPr>
-              <a:t>4</a:t>
+              <a:t>5</a:t>
             </a:r>
           </a:p>
         </p:txBody>
@@ -24679,7 +25390,7 @@
                 </a:solidFill>
                 <a:latin typeface="Calibri"/>
               </a:rPr>
-              <a:t>2</a:t>
+              <a:t>3</a:t>
             </a:r>
           </a:p>
         </p:txBody>
@@ -24868,7 +25579,7 @@
                 </a:solidFill>
                 <a:latin typeface="Calibri"/>
               </a:rPr>
-              <a:t>3</a:t>
+              <a:t>4</a:t>
             </a:r>
           </a:p>
         </p:txBody>
@@ -25057,7 +25768,7 @@
                 </a:solidFill>
                 <a:latin typeface="Calibri"/>
               </a:rPr>
-              <a:t>4</a:t>
+              <a:t>5</a:t>
             </a:r>
           </a:p>
         </p:txBody>
@@ -25246,7 +25957,7 @@
                 </a:solidFill>
                 <a:latin typeface="Calibri"/>
               </a:rPr>
-              <a:t>5</a:t>
+              <a:t>6</a:t>
             </a:r>
           </a:p>
         </p:txBody>
@@ -25683,7 +26394,7 @@
                 </a:solidFill>
                 <a:latin typeface="Calibri"/>
               </a:rPr>
-              <a:t>5</a:t>
+              <a:t>6</a:t>
             </a:r>
           </a:p>
         </p:txBody>
@@ -26074,7 +26785,7 @@
                 </a:solidFill>
                 <a:latin typeface="Calibri"/>
               </a:rPr>
-              <a:t>6</a:t>
+              <a:t>7</a:t>
             </a:r>
           </a:p>
         </p:txBody>
@@ -28355,7 +29066,7 @@
                 </a:solidFill>
                 <a:latin typeface="Calibri"/>
               </a:rPr>
-              <a:t>7</a:t>
+              <a:t>8</a:t>
             </a:r>
           </a:p>
         </p:txBody>
@@ -28667,7 +29378,7 @@
                 </a:solidFill>
                 <a:latin typeface="Calibri"/>
               </a:rPr>
-              <a:t>2</a:t>
+              <a:t>3</a:t>
             </a:r>
           </a:p>
         </p:txBody>
@@ -28856,7 +29567,7 @@
                 </a:solidFill>
                 <a:latin typeface="Calibri"/>
               </a:rPr>
-              <a:t>3</a:t>
+              <a:t>4</a:t>
             </a:r>
           </a:p>
         </p:txBody>
@@ -29045,7 +29756,7 @@
                 </a:solidFill>
                 <a:latin typeface="Calibri"/>
               </a:rPr>
-              <a:t>4</a:t>
+              <a:t>5</a:t>
             </a:r>
           </a:p>
         </p:txBody>
@@ -29615,7 +30326,7 @@
                 </a:solidFill>
                 <a:latin typeface="Calibri"/>
               </a:rPr>
-              <a:t>8</a:t>
+              <a:t>9</a:t>
             </a:r>
           </a:p>
         </p:txBody>
@@ -30717,7 +31428,7 @@
                 </a:solidFill>
                 <a:latin typeface="Calibri"/>
               </a:rPr>
-              <a:t>9</a:t>
+              <a:t>10</a:t>
             </a:r>
           </a:p>
         </p:txBody>

</xml_diff>

<commit_message>
Add intern guide covers, Stripe setup notes, and the Spring 2027 user guide.
Keeps onboarding Help assets on production with the updated in-processing deck.

Co-authored-by: Cursor <cursoragent@cursor.com>
</commit_message>
<xml_diff>
--- a/docs/intern-guide/assets/sitguru-internship-onboarding-inprocessing-spring-2027.pptx
+++ b/docs/intern-guide/assets/sitguru-internship-onboarding-inprocessing-spring-2027.pptx
@@ -6,7 +6,6 @@
   </p:sldMasterIdLst>
   <p:sldIdLst>
     <p:sldId id="256" r:id="rId7"/>
-    <p:sldId id="280" r:id="rId31"/>
     <p:sldId id="257" r:id="rId8"/>
     <p:sldId id="258" r:id="rId9"/>
     <p:sldId id="259" r:id="rId10"/>
@@ -4352,7 +4351,7 @@
                 </a:solidFill>
                 <a:latin typeface="Calibri"/>
               </a:rPr>
-              <a:t>11</a:t>
+              <a:t>10</a:t>
             </a:r>
           </a:p>
         </p:txBody>
@@ -5596,7 +5595,7 @@
                 </a:solidFill>
                 <a:latin typeface="Calibri"/>
               </a:rPr>
-              <a:t>12</a:t>
+              <a:t>11</a:t>
             </a:r>
           </a:p>
         </p:txBody>
@@ -5987,7 +5986,7 @@
                 </a:solidFill>
                 <a:latin typeface="Calibri"/>
               </a:rPr>
-              <a:t>13</a:t>
+              <a:t>12</a:t>
             </a:r>
           </a:p>
         </p:txBody>
@@ -7473,7 +7472,7 @@
                 </a:solidFill>
                 <a:latin typeface="Calibri"/>
               </a:rPr>
-              <a:t>14</a:t>
+              <a:t>13</a:t>
             </a:r>
           </a:p>
         </p:txBody>
@@ -8542,7 +8541,7 @@
                 </a:solidFill>
                 <a:latin typeface="Calibri"/>
               </a:rPr>
-              <a:t>15</a:t>
+              <a:t>14</a:t>
             </a:r>
           </a:p>
         </p:txBody>
@@ -10596,7 +10595,7 @@
                 </a:solidFill>
                 <a:latin typeface="Calibri"/>
               </a:rPr>
-              <a:t>16</a:t>
+              <a:t>15</a:t>
             </a:r>
           </a:p>
         </p:txBody>
@@ -11905,7 +11904,7 @@
                 </a:solidFill>
                 <a:latin typeface="Calibri"/>
               </a:rPr>
-              <a:t>17</a:t>
+              <a:t>16</a:t>
             </a:r>
           </a:p>
         </p:txBody>
@@ -12974,7 +12973,7 @@
                 </a:solidFill>
                 <a:latin typeface="Calibri"/>
               </a:rPr>
-              <a:t>18</a:t>
+              <a:t>17</a:t>
             </a:r>
           </a:p>
         </p:txBody>
@@ -13850,7 +13849,7 @@
                 </a:solidFill>
                 <a:latin typeface="Calibri"/>
               </a:rPr>
-              <a:t>19</a:t>
+              <a:t>18</a:t>
             </a:r>
           </a:p>
         </p:txBody>
@@ -14162,7 +14161,7 @@
                 </a:solidFill>
                 <a:latin typeface="Calibri"/>
               </a:rPr>
-              <a:t>3</a:t>
+              <a:t>2</a:t>
             </a:r>
           </a:p>
         </p:txBody>
@@ -14351,7 +14350,7 @@
                 </a:solidFill>
                 <a:latin typeface="Calibri"/>
               </a:rPr>
-              <a:t>4</a:t>
+              <a:t>3</a:t>
             </a:r>
           </a:p>
         </p:txBody>
@@ -14540,7 +14539,7 @@
                 </a:solidFill>
                 <a:latin typeface="Calibri"/>
               </a:rPr>
-              <a:t>5</a:t>
+              <a:t>4</a:t>
             </a:r>
           </a:p>
         </p:txBody>
@@ -14729,7 +14728,7 @@
                 </a:solidFill>
                 <a:latin typeface="Calibri"/>
               </a:rPr>
-              <a:t>6</a:t>
+              <a:t>5</a:t>
             </a:r>
           </a:p>
         </p:txBody>
@@ -14918,7 +14917,7 @@
                 </a:solidFill>
                 <a:latin typeface="Calibri"/>
               </a:rPr>
-              <a:t>7</a:t>
+              <a:t>6</a:t>
             </a:r>
           </a:p>
         </p:txBody>
@@ -15408,7 +15407,7 @@
                 </a:solidFill>
                 <a:latin typeface="Calibri"/>
               </a:rPr>
-              <a:t>20</a:t>
+              <a:t>19</a:t>
             </a:r>
           </a:p>
         </p:txBody>
@@ -15753,7 +15752,7 @@
                 </a:solidFill>
                 <a:latin typeface="Calibri"/>
               </a:rPr>
-              <a:t>3</a:t>
+              <a:t>2</a:t>
             </a:r>
           </a:p>
         </p:txBody>
@@ -15975,7 +15974,7 @@
                 </a:solidFill>
                 <a:latin typeface="Calibri"/>
               </a:rPr>
-              <a:t>4</a:t>
+              <a:t>3</a:t>
             </a:r>
           </a:p>
         </p:txBody>
@@ -16578,7 +16577,7 @@
                 </a:solidFill>
                 <a:latin typeface="Calibri"/>
               </a:rPr>
-              <a:t>3</a:t>
+              <a:t>2</a:t>
             </a:r>
           </a:p>
         </p:txBody>
@@ -17001,7 +17000,7 @@
                 </a:solidFill>
                 <a:latin typeface="Calibri"/>
               </a:rPr>
-              <a:t>3</a:t>
+              <a:t>2</a:t>
             </a:r>
           </a:p>
         </p:txBody>
@@ -17190,7 +17189,7 @@
                 </a:solidFill>
                 <a:latin typeface="Calibri"/>
               </a:rPr>
-              <a:t>4</a:t>
+              <a:t>3</a:t>
             </a:r>
           </a:p>
         </p:txBody>
@@ -17290,6 +17289,86 @@
                 <a:latin typeface="Calibri"/>
               </a:rPr>
               <a:t>Employer: Graff Enterprises LLC dba SitGuru. Questions: intern@sitguru.com. SitGuru runs the project. Your school counts credits and hours.</a:t>
+            </a:r>
+          </a:p>
+        </p:txBody>
+      </p:sp>
+      <p:sp>
+        <p:nvSpPr>
+          <p:cNvPr id="31" name="Rounded Rectangle 30"/>
+          <p:cNvSpPr/>
+          <p:nvPr/>
+        </p:nvSpPr>
+        <p:spPr>
+          <a:xfrm>
+            <a:off x="384048" y="5943600"/>
+            <a:ext cx="11430000" cy="475488"/>
+          </a:xfrm>
+          <a:prstGeom prst="roundRect">
+            <a:avLst>
+              <a:gd name="adj" fmla="val 18000"/>
+            </a:avLst>
+          </a:prstGeom>
+          <a:solidFill>
+            <a:srgbClr val="166534"/>
+          </a:solidFill>
+          <a:ln>
+            <a:noFill/>
+          </a:ln>
+        </p:spPr>
+        <p:style>
+          <a:lnRef idx="1">
+            <a:schemeClr val="accent1"/>
+          </a:lnRef>
+          <a:fillRef idx="3">
+            <a:schemeClr val="accent1"/>
+          </a:fillRef>
+          <a:effectRef idx="2">
+            <a:schemeClr val="accent1"/>
+          </a:effectRef>
+          <a:fontRef idx="minor">
+            <a:schemeClr val="lt1"/>
+          </a:fontRef>
+        </p:style>
+        <p:txBody>
+          <a:bodyPr rtlCol="0" anchor="ctr"/>
+          <a:lstStyle/>
+          <a:p>
+            <a:pPr algn="ctr"/>
+          </a:p>
+        </p:txBody>
+      </p:sp>
+      <p:sp>
+        <p:nvSpPr>
+          <p:cNvPr id="32" name="TextBox 31"/>
+          <p:cNvSpPr txBox="1"/>
+          <p:nvPr/>
+        </p:nvSpPr>
+        <p:spPr>
+          <a:xfrm>
+            <a:off x="530352" y="5998464"/>
+            <a:ext cx="11155680" cy="365760"/>
+          </a:xfrm>
+          <a:prstGeom prst="rect">
+            <a:avLst/>
+          </a:prstGeom>
+          <a:noFill/>
+        </p:spPr>
+        <p:txBody>
+          <a:bodyPr wrap="square" anchor="ctr">
+            <a:spAutoFit/>
+          </a:bodyPr>
+          <a:lstStyle/>
+          <a:p>
+            <a:pPr algn="ctr"/>
+            <a:r>
+              <a:rPr sz="1400" b="1">
+                <a:solidFill>
+                  <a:srgbClr val="FFFFFF"/>
+                </a:solidFill>
+                <a:latin typeface="Calibri"/>
+              </a:rPr>
+              <a:t>Live session starts with a short watch-together clip. Then we do inprocessing in this deck.</a:t>
             </a:r>
           </a:p>
         </p:txBody>
@@ -17680,7 +17759,7 @@
                 </a:solidFill>
                 <a:latin typeface="Calibri"/>
               </a:rPr>
-              <a:t>21</a:t>
+              <a:t>20</a:t>
             </a:r>
           </a:p>
         </p:txBody>
@@ -18980,7 +19059,7 @@
                 </a:solidFill>
                 <a:latin typeface="Calibri"/>
               </a:rPr>
-              <a:t>22</a:t>
+              <a:t>21</a:t>
             </a:r>
           </a:p>
         </p:txBody>
@@ -20049,7 +20128,7 @@
                 </a:solidFill>
                 <a:latin typeface="Calibri"/>
               </a:rPr>
-              <a:t>23</a:t>
+              <a:t>22</a:t>
             </a:r>
           </a:p>
         </p:txBody>
@@ -21184,7 +21263,7 @@
                 </a:solidFill>
                 <a:latin typeface="Calibri"/>
               </a:rPr>
-              <a:t>24</a:t>
+              <a:t>23</a:t>
             </a:r>
           </a:p>
         </p:txBody>
@@ -21463,7 +21542,7 @@
                 </a:solidFill>
                 <a:latin typeface="Calibri"/>
               </a:rPr>
-              <a:t>3</a:t>
+              <a:t>2</a:t>
             </a:r>
           </a:p>
         </p:txBody>
@@ -21619,7 +21698,7 @@
                 </a:solidFill>
                 <a:latin typeface="Calibri"/>
               </a:rPr>
-              <a:t>4</a:t>
+              <a:t>3</a:t>
             </a:r>
           </a:p>
         </p:txBody>
@@ -21775,7 +21854,7 @@
                 </a:solidFill>
                 <a:latin typeface="Calibri"/>
               </a:rPr>
-              <a:t>5</a:t>
+              <a:t>4</a:t>
             </a:r>
           </a:p>
         </p:txBody>
@@ -21931,7 +22010,7 @@
                 </a:solidFill>
                 <a:latin typeface="Calibri"/>
               </a:rPr>
-              <a:t>6</a:t>
+              <a:t>5</a:t>
             </a:r>
           </a:p>
         </p:txBody>
@@ -22087,7 +22166,7 @@
                 </a:solidFill>
                 <a:latin typeface="Calibri"/>
               </a:rPr>
-              <a:t>7</a:t>
+              <a:t>6</a:t>
             </a:r>
           </a:p>
         </p:txBody>
@@ -22243,7 +22322,7 @@
                 </a:solidFill>
                 <a:latin typeface="Calibri"/>
               </a:rPr>
-              <a:t>8</a:t>
+              <a:t>7</a:t>
             </a:r>
           </a:p>
         </p:txBody>
@@ -22399,7 +22478,7 @@
                 </a:solidFill>
                 <a:latin typeface="Calibri"/>
               </a:rPr>
-              <a:t>9</a:t>
+              <a:t>8</a:t>
             </a:r>
           </a:p>
         </p:txBody>
@@ -22873,717 +22952,7 @@
                 </a:solidFill>
                 <a:latin typeface="Calibri"/>
               </a:rPr>
-              <a:t>25</a:t>
-            </a:r>
-          </a:p>
-        </p:txBody>
-      </p:sp>
-    </p:spTree>
-  </p:cSld>
-  <p:clrMapOvr>
-    <a:masterClrMapping/>
-  </p:clrMapOvr>
-</p:sld>
-</file>
-
-<file path=ppt/slides/slide25.xml><?xml version="1.0" encoding="utf-8"?>
-<p:sld xmlns:a="http://schemas.openxmlformats.org/drawingml/2006/main" xmlns:p="http://schemas.openxmlformats.org/presentationml/2006/main" xmlns:r="http://schemas.openxmlformats.org/officeDocument/2006/relationships">
-  <p:cSld>
-    <p:spTree>
-      <p:nvGrpSpPr>
-        <p:cNvPr id="1" name=""/>
-        <p:cNvGrpSpPr/>
-        <p:nvPr/>
-      </p:nvGrpSpPr>
-      <p:grpSpPr/>
-      <p:sp>
-        <p:nvSpPr>
-          <p:cNvPr id="2" name="Rectangle 1"/>
-          <p:cNvSpPr/>
-          <p:nvPr/>
-        </p:nvSpPr>
-        <p:spPr>
-          <a:xfrm>
-            <a:off x="0" y="0"/>
-            <a:ext cx="12191695" cy="6858000"/>
-          </a:xfrm>
-          <a:prstGeom prst="rect">
-            <a:avLst/>
-          </a:prstGeom>
-          <a:solidFill>
-            <a:srgbClr val="F3F8F4"/>
-          </a:solidFill>
-          <a:ln>
-            <a:noFill/>
-          </a:ln>
-        </p:spPr>
-        <p:style>
-          <a:lnRef idx="1">
-            <a:schemeClr val="accent1"/>
-          </a:lnRef>
-          <a:fillRef idx="3">
-            <a:schemeClr val="accent1"/>
-          </a:fillRef>
-          <a:effectRef idx="2">
-            <a:schemeClr val="accent1"/>
-          </a:effectRef>
-          <a:fontRef idx="minor">
-            <a:schemeClr val="lt1"/>
-          </a:fontRef>
-        </p:style>
-        <p:txBody>
-          <a:bodyPr rtlCol="0" anchor="ctr"/>
-          <a:lstStyle/>
-          <a:p>
-            <a:pPr algn="ctr"/>
-          </a:p>
-        </p:txBody>
-      </p:sp>
-      <p:sp>
-        <p:nvSpPr>
-          <p:cNvPr id="3" name="Rectangle 2"/>
-          <p:cNvSpPr/>
-          <p:nvPr/>
-        </p:nvSpPr>
-        <p:spPr>
-          <a:xfrm>
-            <a:off x="0" y="0"/>
-            <a:ext cx="12191695" cy="1078992"/>
-          </a:xfrm>
-          <a:prstGeom prst="rect">
-            <a:avLst/>
-          </a:prstGeom>
-          <a:solidFill>
-            <a:srgbClr val="166534"/>
-          </a:solidFill>
-          <a:ln>
-            <a:noFill/>
-          </a:ln>
-        </p:spPr>
-        <p:style>
-          <a:lnRef idx="1">
-            <a:schemeClr val="accent1"/>
-          </a:lnRef>
-          <a:fillRef idx="3">
-            <a:schemeClr val="accent1"/>
-          </a:fillRef>
-          <a:effectRef idx="2">
-            <a:schemeClr val="accent1"/>
-          </a:effectRef>
-          <a:fontRef idx="minor">
-            <a:schemeClr val="lt1"/>
-          </a:fontRef>
-        </p:style>
-        <p:txBody>
-          <a:bodyPr rtlCol="0" anchor="ctr"/>
-          <a:lstStyle/>
-          <a:p>
-            <a:pPr algn="ctr"/>
-          </a:p>
-        </p:txBody>
-      </p:sp>
-      <p:sp>
-        <p:nvSpPr>
-          <p:cNvPr id="4" name="Rectangle 3"/>
-          <p:cNvSpPr/>
-          <p:nvPr/>
-        </p:nvSpPr>
-        <p:spPr>
-          <a:xfrm>
-            <a:off x="0" y="1078992"/>
-            <a:ext cx="12191695" cy="54864"/>
-          </a:xfrm>
-          <a:prstGeom prst="rect">
-            <a:avLst/>
-          </a:prstGeom>
-          <a:solidFill>
-            <a:srgbClr val="102417"/>
-          </a:solidFill>
-          <a:ln>
-            <a:noFill/>
-          </a:ln>
-        </p:spPr>
-        <p:style>
-          <a:lnRef idx="1">
-            <a:schemeClr val="accent1"/>
-          </a:lnRef>
-          <a:fillRef idx="3">
-            <a:schemeClr val="accent1"/>
-          </a:fillRef>
-          <a:effectRef idx="2">
-            <a:schemeClr val="accent1"/>
-          </a:effectRef>
-          <a:fontRef idx="minor">
-            <a:schemeClr val="lt1"/>
-          </a:fontRef>
-        </p:style>
-        <p:txBody>
-          <a:bodyPr rtlCol="0" anchor="ctr"/>
-          <a:lstStyle/>
-          <a:p>
-            <a:pPr algn="ctr"/>
-          </a:p>
-        </p:txBody>
-      </p:sp>
-      <p:sp>
-        <p:nvSpPr>
-          <p:cNvPr id="5" name="TextBox 4"/>
-          <p:cNvSpPr txBox="1"/>
-          <p:nvPr/>
-        </p:nvSpPr>
-        <p:spPr>
-          <a:xfrm>
-            <a:off x="384048" y="164592"/>
-            <a:ext cx="9692640" cy="475488"/>
-          </a:xfrm>
-          <a:prstGeom prst="rect">
-            <a:avLst/>
-          </a:prstGeom>
-          <a:noFill/>
-        </p:spPr>
-        <p:txBody>
-          <a:bodyPr wrap="square" anchor="ctr"/>
-          <a:lstStyle/>
-          <a:p>
-            <a:pPr algn="l"/>
-            <a:r>
-              <a:rPr sz="2600" b="1">
-                <a:solidFill>
-                  <a:srgbClr val="FFFFFF"/>
-                </a:solidFill>
-                <a:latin typeface="Calibri"/>
-              </a:rPr>
-              <a:t>Watch this first</a:t>
-            </a:r>
-          </a:p>
-        </p:txBody>
-      </p:sp>
-      <p:sp>
-        <p:nvSpPr>
-          <p:cNvPr id="6" name="TextBox 5"/>
-          <p:cNvSpPr txBox="1"/>
-          <p:nvPr/>
-        </p:nvSpPr>
-        <p:spPr>
-          <a:xfrm>
-            <a:off x="384048" y="621792"/>
-            <a:ext cx="9692640" cy="347472"/>
-          </a:xfrm>
-          <a:prstGeom prst="rect">
-            <a:avLst/>
-          </a:prstGeom>
-          <a:noFill/>
-        </p:spPr>
-        <p:txBody>
-          <a:bodyPr wrap="square" anchor="t"/>
-          <a:lstStyle/>
-          <a:p>
-            <a:pPr algn="l"/>
-            <a:r>
-              <a:rPr sz="1300" b="0">
-                <a:solidFill>
-                  <a:srgbClr val="CFE6D5"/>
-                </a:solidFill>
-                <a:latin typeface="Calibri"/>
-              </a:rPr>
-              <a:t>Set the tone. Break the ice. Then we onboard.</a:t>
-            </a:r>
-          </a:p>
-        </p:txBody>
-      </p:sp>
-      <p:sp>
-        <p:nvSpPr>
-          <p:cNvPr id="7" name="Rounded Rectangle 6"/>
-          <p:cNvSpPr/>
-          <p:nvPr/>
-        </p:nvSpPr>
-        <p:spPr>
-          <a:xfrm>
-            <a:off x="10561320" y="201168"/>
-            <a:ext cx="1261872" cy="676656"/>
-          </a:xfrm>
-          <a:prstGeom prst="roundRect">
-            <a:avLst>
-              <a:gd name="adj" fmla="val 18000"/>
-            </a:avLst>
-          </a:prstGeom>
-          <a:solidFill>
-            <a:srgbClr val="FFFFFF"/>
-          </a:solidFill>
-          <a:ln>
-            <a:noFill/>
-          </a:ln>
-        </p:spPr>
-        <p:style>
-          <a:lnRef idx="1">
-            <a:schemeClr val="accent1"/>
-          </a:lnRef>
-          <a:fillRef idx="3">
-            <a:schemeClr val="accent1"/>
-          </a:fillRef>
-          <a:effectRef idx="2">
-            <a:schemeClr val="accent1"/>
-          </a:effectRef>
-          <a:fontRef idx="minor">
-            <a:schemeClr val="lt1"/>
-          </a:fontRef>
-        </p:style>
-        <p:txBody>
-          <a:bodyPr rtlCol="0" anchor="ctr"/>
-          <a:lstStyle/>
-          <a:p>
-            <a:pPr algn="ctr"/>
-          </a:p>
-        </p:txBody>
-      </p:sp>
-      <p:pic>
-        <p:nvPicPr>
-          <p:cNvPr id="8" name="Picture 7" descr="image.jpg"/>
-          <p:cNvPicPr>
-            <a:picLocks noChangeAspect="1"/>
-          </p:cNvPicPr>
-          <p:nvPr/>
-        </p:nvPicPr>
-        <p:blipFill>
-          <a:blip r:embed="rId2"/>
-          <a:stretch>
-            <a:fillRect/>
-          </a:stretch>
-        </p:blipFill>
-        <p:spPr>
-          <a:xfrm>
-            <a:off x="10808208" y="256032"/>
-            <a:ext cx="768096" cy="566928"/>
-          </a:xfrm>
-          <a:prstGeom prst="rect">
-            <a:avLst/>
-          </a:prstGeom>
-        </p:spPr>
-      </p:pic>
-      <p:sp>
-        <p:nvSpPr>
-          <p:cNvPr id="9" name="TextBox 8"/>
-          <p:cNvSpPr txBox="1"/>
-          <p:nvPr/>
-        </p:nvSpPr>
-        <p:spPr>
-          <a:xfrm>
-            <a:off x="384048" y="1335024"/>
-            <a:ext cx="6537960" cy="1051560"/>
-          </a:xfrm>
-          <a:prstGeom prst="rect">
-            <a:avLst/>
-          </a:prstGeom>
-          <a:noFill/>
-        </p:spPr>
-        <p:txBody>
-          <a:bodyPr wrap="square" anchor="t"/>
-          <a:lstStyle/>
-          <a:p>
-            <a:pPr algn="l"/>
-            <a:r>
-              <a:rPr sz="1800" b="1">
-                <a:solidFill>
-                  <a:srgbClr val="0F172A"/>
-                </a:solidFill>
-                <a:latin typeface="Calibri"/>
-              </a:rPr>
-              <a:t>Hit play together — or watch on your own. This is the icebreaker before the agreement, hours, and portal work. Rogue energy: high-energy, loving, then we get to work.</a:t>
-            </a:r>
-          </a:p>
-        </p:txBody>
-      </p:sp>
-      <p:sp>
-        <p:nvSpPr>
-          <p:cNvPr id="10" name="TextBox 9"/>
-          <p:cNvSpPr txBox="1"/>
-          <p:nvPr/>
-        </p:nvSpPr>
-        <p:spPr>
-          <a:xfrm>
-            <a:off x="384048" y="2450592"/>
-            <a:ext cx="6537960" cy="777240"/>
-          </a:xfrm>
-          <a:prstGeom prst="rect">
-            <a:avLst/>
-          </a:prstGeom>
-          <a:noFill/>
-        </p:spPr>
-        <p:txBody>
-          <a:bodyPr wrap="square" anchor="t"/>
-          <a:lstStyle/>
-          <a:p>
-            <a:pPr algn="l"/>
-            <a:r>
-              <a:rPr sz="1500" b="0">
-                <a:solidFill>
-                  <a:srgbClr val="475569"/>
-                </a:solidFill>
-                <a:latin typeface="Calibri"/>
-              </a:rPr>
-              <a:t>Start at 12:29 (t=749s). Official talk title: Why social media deserves a seat in the c-suite.</a:t>
-            </a:r>
-          </a:p>
-        </p:txBody>
-      </p:sp>
-      <p:pic>
-        <p:nvPicPr>
-          <p:cNvPr id="11" name="Picture 10" descr="_yt-Zzv6Opxkt88.jpg">
-            <a:hlinkClick r:id="rId4"/>
-          </p:cNvPr>
-          <p:cNvPicPr>
-            <a:picLocks noChangeAspect="1"/>
-          </p:cNvPicPr>
-          <p:nvPr/>
-        </p:nvPicPr>
-        <p:blipFill>
-          <a:blip r:embed="rId3"/>
-          <a:stretch>
-            <a:fillRect/>
-          </a:stretch>
-        </p:blipFill>
-        <p:spPr>
-          <a:xfrm>
-            <a:off x="7360920" y="1371600"/>
-            <a:ext cx="4434840" cy="2487168"/>
-          </a:xfrm>
-          <a:prstGeom prst="rect">
-            <a:avLst/>
-          </a:prstGeom>
-        </p:spPr>
-      </p:pic>
-      <p:sp>
-        <p:nvSpPr>
-          <p:cNvPr id="12" name="Rounded Rectangle 11">
-            <a:hlinkClick r:id="rId4"/>
-          </p:cNvPr>
-          <p:cNvSpPr/>
-          <p:nvPr/>
-        </p:nvSpPr>
-        <p:spPr>
-          <a:xfrm>
-            <a:off x="9144000" y="2267712"/>
-            <a:ext cx="914400" cy="658368"/>
-          </a:xfrm>
-          <a:prstGeom prst="roundRect">
-            <a:avLst>
-              <a:gd name="adj" fmla="val 25000"/>
-            </a:avLst>
-          </a:prstGeom>
-          <a:solidFill>
-            <a:srgbClr val="166534"/>
-          </a:solidFill>
-          <a:ln>
-            <a:noFill/>
-          </a:ln>
-        </p:spPr>
-        <p:style>
-          <a:lnRef idx="1">
-            <a:schemeClr val="accent1"/>
-          </a:lnRef>
-          <a:fillRef idx="3">
-            <a:schemeClr val="accent1"/>
-          </a:fillRef>
-          <a:effectRef idx="2">
-            <a:schemeClr val="accent1"/>
-          </a:effectRef>
-          <a:fontRef idx="minor">
-            <a:schemeClr val="lt1"/>
-          </a:fontRef>
-        </p:style>
-        <p:txBody>
-          <a:bodyPr rtlCol="0" anchor="ctr"/>
-          <a:lstStyle/>
-          <a:p>
-            <a:pPr algn="ctr"/>
-          </a:p>
-        </p:txBody>
-      </p:sp>
-      <p:sp>
-        <p:nvSpPr>
-          <p:cNvPr id="13" name="TextBox 12"/>
-          <p:cNvSpPr txBox="1"/>
-          <p:nvPr/>
-        </p:nvSpPr>
-        <p:spPr>
-          <a:xfrm>
-            <a:off x="9144000" y="2359152"/>
-            <a:ext cx="914400" cy="475488"/>
-          </a:xfrm>
-          <a:prstGeom prst="rect">
-            <a:avLst/>
-          </a:prstGeom>
-          <a:noFill/>
-        </p:spPr>
-        <p:txBody>
-          <a:bodyPr wrap="square" anchor="ctr"/>
-          <a:lstStyle/>
-          <a:p>
-            <a:pPr algn="ctr"/>
-            <a:r>
-              <a:rPr sz="2200" b="1">
-                <a:solidFill>
-                  <a:srgbClr val="FFFFFF"/>
-                </a:solidFill>
-                <a:latin typeface="Calibri"/>
-              </a:rPr>
-              <a:t>▶</a:t>
-            </a:r>
-          </a:p>
-        </p:txBody>
-      </p:sp>
-      <p:sp>
-        <p:nvSpPr>
-          <p:cNvPr id="14" name="Rounded Rectangle 13">
-            <a:hlinkClick r:id="rId4"/>
-          </p:cNvPr>
-          <p:cNvSpPr/>
-          <p:nvPr/>
-        </p:nvSpPr>
-        <p:spPr>
-          <a:xfrm>
-            <a:off x="384048" y="3383280"/>
-            <a:ext cx="6537960" cy="960120"/>
-          </a:xfrm>
-          <a:prstGeom prst="roundRect">
-            <a:avLst>
-              <a:gd name="adj" fmla="val 12000"/>
-            </a:avLst>
-          </a:prstGeom>
-          <a:solidFill>
-            <a:srgbClr val="166534"/>
-          </a:solidFill>
-          <a:ln>
-            <a:noFill/>
-          </a:ln>
-        </p:spPr>
-        <p:style>
-          <a:lnRef idx="1">
-            <a:schemeClr val="accent1"/>
-          </a:lnRef>
-          <a:fillRef idx="3">
-            <a:schemeClr val="accent1"/>
-          </a:fillRef>
-          <a:effectRef idx="2">
-            <a:schemeClr val="accent1"/>
-          </a:effectRef>
-          <a:fontRef idx="minor">
-            <a:schemeClr val="lt1"/>
-          </a:fontRef>
-        </p:style>
-        <p:txBody>
-          <a:bodyPr rtlCol="0" anchor="ctr"/>
-          <a:lstStyle/>
-          <a:p>
-            <a:pPr algn="ctr"/>
-          </a:p>
-        </p:txBody>
-      </p:sp>
-      <p:sp>
-        <p:nvSpPr>
-          <p:cNvPr id="15" name="TextBox 14"/>
-          <p:cNvSpPr txBox="1"/>
-          <p:nvPr/>
-        </p:nvSpPr>
-        <p:spPr>
-          <a:xfrm>
-            <a:off x="530352" y="3529584"/>
-            <a:ext cx="6263640" cy="658368"/>
-          </a:xfrm>
-          <a:prstGeom prst="rect">
-            <a:avLst/>
-          </a:prstGeom>
-          <a:noFill/>
-        </p:spPr>
-        <p:txBody>
-          <a:bodyPr wrap="square" anchor="ctr"/>
-          <a:lstStyle/>
-          <a:p>
-            <a:pPr algn="ctr"/>
-            <a:r>
-              <a:rPr sz="2200" b="1">
-                <a:solidFill>
-                  <a:srgbClr val="FFFFFF"/>
-                </a:solidFill>
-                <a:latin typeface="Calibri"/>
-              </a:rPr>
-              <a:t>Watch the SitGuru icebreaker  →</a:t>
-            </a:r>
-          </a:p>
-        </p:txBody>
-      </p:sp>
-      <p:sp>
-        <p:nvSpPr>
-          <p:cNvPr id="16" name="TextBox 15"/>
-          <p:cNvSpPr txBox="1"/>
-          <p:nvPr/>
-        </p:nvSpPr>
-        <p:spPr>
-          <a:xfrm>
-            <a:off x="384048" y="4480560"/>
-            <a:ext cx="11430000" cy="384048"/>
-          </a:xfrm>
-          <a:prstGeom prst="rect">
-            <a:avLst/>
-          </a:prstGeom>
-          <a:noFill/>
-        </p:spPr>
-        <p:txBody>
-          <a:bodyPr wrap="square" anchor="t"/>
-          <a:lstStyle/>
-          <a:p>
-            <a:pPr algn="l"/>
-            <a:r>
-              <a:rPr sz="1400" b="1">
-                <a:solidFill>
-                  <a:srgbClr val="166534"/>
-                </a:solidFill>
-                <a:latin typeface="Calibri"/>
-                <a:hlinkClick r:id="rId4"/>
-              </a:rPr>
-              <a:t>https://www.youtube.com/watch?v=Zzv6Opxkt88&amp;t=749s</a:t>
-            </a:r>
-          </a:p>
-        </p:txBody>
-      </p:sp>
-      <p:sp>
-        <p:nvSpPr>
-          <p:cNvPr id="17" name="TextBox 16"/>
-          <p:cNvSpPr txBox="1"/>
-          <p:nvPr/>
-        </p:nvSpPr>
-        <p:spPr>
-          <a:xfrm>
-            <a:off x="384048" y="4919472"/>
-            <a:ext cx="11430000" cy="1371600"/>
-          </a:xfrm>
-          <a:prstGeom prst="rect">
-            <a:avLst/>
-          </a:prstGeom>
-          <a:noFill/>
-        </p:spPr>
-        <p:txBody>
-          <a:bodyPr wrap="square" anchor="t"/>
-          <a:lstStyle/>
-          <a:p>
-            <a:pPr algn="l"/>
-            <a:r>
-              <a:rPr sz="1500" b="0">
-                <a:solidFill>
-                  <a:srgbClr val="475569"/>
-                </a:solidFill>
-                <a:latin typeface="Calibri"/>
-              </a:rPr>
-              <a:t>That exact URL opens at 12:29. No video file lives in this deck — click the link. Then come back for onboarding. Questions: intern@sitguru.com.</a:t>
-            </a:r>
-          </a:p>
-        </p:txBody>
-      </p:sp>
-      <p:sp>
-        <p:nvSpPr>
-          <p:cNvPr id="18" name="Rectangle 17"/>
-          <p:cNvSpPr/>
-          <p:nvPr/>
-        </p:nvSpPr>
-        <p:spPr>
-          <a:xfrm>
-            <a:off x="0" y="6510528"/>
-            <a:ext cx="12191695" cy="347472"/>
-          </a:xfrm>
-          <a:prstGeom prst="rect">
-            <a:avLst/>
-          </a:prstGeom>
-          <a:solidFill>
-            <a:srgbClr val="F3F8F4"/>
-          </a:solidFill>
-          <a:ln>
-            <a:noFill/>
-          </a:ln>
-        </p:spPr>
-        <p:style>
-          <a:lnRef idx="1">
-            <a:schemeClr val="accent1"/>
-          </a:lnRef>
-          <a:fillRef idx="3">
-            <a:schemeClr val="accent1"/>
-          </a:fillRef>
-          <a:effectRef idx="2">
-            <a:schemeClr val="accent1"/>
-          </a:effectRef>
-          <a:fontRef idx="minor">
-            <a:schemeClr val="lt1"/>
-          </a:fontRef>
-        </p:style>
-        <p:txBody>
-          <a:bodyPr rtlCol="0" anchor="ctr"/>
-          <a:lstStyle/>
-          <a:p>
-            <a:pPr algn="ctr"/>
-          </a:p>
-        </p:txBody>
-      </p:sp>
-      <p:sp>
-        <p:nvSpPr>
-          <p:cNvPr id="19" name="TextBox 18"/>
-          <p:cNvSpPr txBox="1"/>
-          <p:nvPr/>
-        </p:nvSpPr>
-        <p:spPr>
-          <a:xfrm>
-            <a:off x="384048" y="6547104"/>
-            <a:ext cx="10515600" cy="274320"/>
-          </a:xfrm>
-          <a:prstGeom prst="rect">
-            <a:avLst/>
-          </a:prstGeom>
-          <a:noFill/>
-        </p:spPr>
-        <p:txBody>
-          <a:bodyPr wrap="square" anchor="ctr"/>
-          <a:lstStyle/>
-          <a:p>
-            <a:pPr algn="l"/>
-            <a:r>
-              <a:rPr sz="800" b="0">
-                <a:solidFill>
-                  <a:srgbClr val="64748B"/>
-                </a:solidFill>
-                <a:latin typeface="Calibri"/>
-              </a:rPr>
-              <a:t>© SitGuru. Proprietary and confidential. This user guide belongs solely to SitGuru and may not be copied, reproduced, distributed, shared, or used in whole or in part without prior written permission from SitGuru.</a:t>
-            </a:r>
-          </a:p>
-        </p:txBody>
-      </p:sp>
-      <p:sp>
-        <p:nvSpPr>
-          <p:cNvPr id="20" name="TextBox 19"/>
-          <p:cNvSpPr txBox="1"/>
-          <p:nvPr/>
-        </p:nvSpPr>
-        <p:spPr>
-          <a:xfrm>
-            <a:off x="10927080" y="6547104"/>
-            <a:ext cx="914400" cy="274320"/>
-          </a:xfrm>
-          <a:prstGeom prst="rect">
-            <a:avLst/>
-          </a:prstGeom>
-          <a:noFill/>
-        </p:spPr>
-        <p:txBody>
-          <a:bodyPr wrap="square" anchor="ctr"/>
-          <a:lstStyle/>
-          <a:p>
-            <a:pPr algn="r"/>
-            <a:r>
-              <a:rPr sz="1000" b="1">
-                <a:solidFill>
-                  <a:srgbClr val="166534"/>
-                </a:solidFill>
-                <a:latin typeface="Calibri"/>
-              </a:rPr>
-              <a:t>2</a:t>
+              <a:t>24</a:t>
             </a:r>
           </a:p>
         </p:txBody>
@@ -23974,7 +23343,7 @@
                 </a:solidFill>
                 <a:latin typeface="Calibri"/>
               </a:rPr>
-              <a:t>4</a:t>
+              <a:t>3</a:t>
             </a:r>
           </a:p>
         </p:txBody>
@@ -24319,7 +23688,7 @@
                 </a:solidFill>
                 <a:latin typeface="Calibri"/>
               </a:rPr>
-              <a:t>3</a:t>
+              <a:t>2</a:t>
             </a:r>
           </a:p>
         </p:txBody>
@@ -24508,7 +23877,7 @@
                 </a:solidFill>
                 <a:latin typeface="Calibri"/>
               </a:rPr>
-              <a:t>4</a:t>
+              <a:t>3</a:t>
             </a:r>
           </a:p>
         </p:txBody>
@@ -25078,7 +24447,7 @@
                 </a:solidFill>
                 <a:latin typeface="Calibri"/>
               </a:rPr>
-              <a:t>5</a:t>
+              <a:t>4</a:t>
             </a:r>
           </a:p>
         </p:txBody>
@@ -25390,7 +24759,7 @@
                 </a:solidFill>
                 <a:latin typeface="Calibri"/>
               </a:rPr>
-              <a:t>3</a:t>
+              <a:t>2</a:t>
             </a:r>
           </a:p>
         </p:txBody>
@@ -25579,7 +24948,7 @@
                 </a:solidFill>
                 <a:latin typeface="Calibri"/>
               </a:rPr>
-              <a:t>4</a:t>
+              <a:t>3</a:t>
             </a:r>
           </a:p>
         </p:txBody>
@@ -25768,7 +25137,7 @@
                 </a:solidFill>
                 <a:latin typeface="Calibri"/>
               </a:rPr>
-              <a:t>5</a:t>
+              <a:t>4</a:t>
             </a:r>
           </a:p>
         </p:txBody>
@@ -25957,7 +25326,7 @@
                 </a:solidFill>
                 <a:latin typeface="Calibri"/>
               </a:rPr>
-              <a:t>6</a:t>
+              <a:t>5</a:t>
             </a:r>
           </a:p>
         </p:txBody>
@@ -26394,7 +25763,7 @@
                 </a:solidFill>
                 <a:latin typeface="Calibri"/>
               </a:rPr>
-              <a:t>6</a:t>
+              <a:t>5</a:t>
             </a:r>
           </a:p>
         </p:txBody>
@@ -26785,7 +26154,7 @@
                 </a:solidFill>
                 <a:latin typeface="Calibri"/>
               </a:rPr>
-              <a:t>7</a:t>
+              <a:t>6</a:t>
             </a:r>
           </a:p>
         </p:txBody>
@@ -29066,7 +28435,7 @@
                 </a:solidFill>
                 <a:latin typeface="Calibri"/>
               </a:rPr>
-              <a:t>8</a:t>
+              <a:t>7</a:t>
             </a:r>
           </a:p>
         </p:txBody>
@@ -29378,7 +28747,7 @@
                 </a:solidFill>
                 <a:latin typeface="Calibri"/>
               </a:rPr>
-              <a:t>3</a:t>
+              <a:t>2</a:t>
             </a:r>
           </a:p>
         </p:txBody>
@@ -29567,7 +28936,7 @@
                 </a:solidFill>
                 <a:latin typeface="Calibri"/>
               </a:rPr>
-              <a:t>4</a:t>
+              <a:t>3</a:t>
             </a:r>
           </a:p>
         </p:txBody>
@@ -29756,7 +29125,7 @@
                 </a:solidFill>
                 <a:latin typeface="Calibri"/>
               </a:rPr>
-              <a:t>5</a:t>
+              <a:t>4</a:t>
             </a:r>
           </a:p>
         </p:txBody>
@@ -30326,7 +29695,7 @@
                 </a:solidFill>
                 <a:latin typeface="Calibri"/>
               </a:rPr>
-              <a:t>9</a:t>
+              <a:t>8</a:t>
             </a:r>
           </a:p>
         </p:txBody>
@@ -31428,7 +30797,7 @@
                 </a:solidFill>
                 <a:latin typeface="Calibri"/>
               </a:rPr>
-              <a:t>10</a:t>
+              <a:t>9</a:t>
             </a:r>
           </a:p>
         </p:txBody>

</xml_diff>